<commit_message>
IHK-Deck: Achsen der Einsatzfelder-Landkarte definiert und vergrößert
Co-Authored-By: Claude Opus 5.5 <noreply@anthropic.com>
Claude-Session: https://claude.ai/code/session_01Sxpnj712vLDdH4Pir29eLC
</commit_message>
<xml_diff>
--- a/docs/praesentation/Verordnungs-Check_IHK_3x15min_2026-10-23.pptx
+++ b/docs/praesentation/Verordnungs-Check_IHK_3x15min_2026-10-23.pptx
@@ -136,7 +136,7 @@
   <p:extLst>
     <p:ext uri="{521415D9-36F7-43E2-AB2F-B90AF26B5E84}">
       <p14:sectionLst xmlns:p14="http://schemas.microsoft.com/office/powerpoint/2010/main">
-        <p14:section name="Thomas: Ist/Soll und Business Case" id="{d3643711-0a47-4ac8-51d3-9d6bdf72f52e}">
+        <p14:section name="Thomas: Ist/Soll und Business Case" id="{f30849dd-a60b-66bd-0a71-bd762ec44f12}">
           <p14:sldIdLst>
             <p14:sldId id="256"/>
             <p14:sldId id="257"/>
@@ -148,7 +148,7 @@
             <p14:sldId id="263"/>
           </p14:sldIdLst>
         </p14:section>
-        <p14:section name="Valentin: Tools, Architektur, Governance" id="{1d5d4184-4fea-45d9-a995-b04acb26b584}">
+        <p14:section name="Valentin: Tools, Architektur, Governance" id="{66aac475-47ba-716a-6e8d-1b557e92ec73}">
           <p14:sldIdLst>
             <p14:sldId id="264"/>
             <p14:sldId id="265"/>
@@ -163,7 +163,7 @@
             <p14:sldId id="274"/>
           </p14:sldIdLst>
         </p14:section>
-        <p14:section name="Derk: Prüfer, Messung, Einsatz" id="{9d4fe525-abc2-27c4-95dd-a2fbacc67214}">
+        <p14:section name="Derk: Prüfer, Messung, Einsatz" id="{84b0dbb0-2f06-2755-b2e2-91d8ec01e411}">
           <p14:sldIdLst>
             <p14:sldId id="275"/>
             <p14:sldId id="276"/>
@@ -175,13 +175,13 @@
             <p14:sldId id="282"/>
           </p14:sldIdLst>
         </p14:section>
-        <p14:section name="Thomas: Schluss" id="{1958cdee-e391-10c1-8f90-b1a9fe6e3955}">
+        <p14:section name="Thomas: Schluss" id="{af014d88-f06a-9fcb-4ed2-93b5ea18d7cd}">
           <p14:sldIdLst>
             <p14:sldId id="283"/>
             <p14:sldId id="284"/>
           </p14:sldIdLst>
         </p14:section>
-        <p14:section name="Anhang" id="{a447f35c-e237-9f09-9893-2aa0f3616eae}">
+        <p14:section name="Anhang" id="{c354d3dd-26c4-6504-7f33-dc42369aea50}">
           <p14:sldIdLst>
             <p14:sldId id="285"/>
           </p14:sldIdLst>
@@ -41098,12 +41098,12 @@
         </p:nvSpPr>
         <p:spPr>
           <a:xfrm>
-            <a:off x="548640" y="1325880"/>
-            <a:ext cx="6492240" cy="4297680"/>
+            <a:off x="1965960" y="1325880"/>
+            <a:ext cx="5074920" cy="3611880"/>
           </a:xfrm>
           <a:prstGeom prst="roundRect">
             <a:avLst>
-              <a:gd name="adj" fmla="val 1702"/>
+              <a:gd name="adj" fmla="val 2025"/>
             </a:avLst>
           </a:prstGeom>
           <a:solidFill>
@@ -41120,8 +41120,8 @@
         </p:nvSpPr>
         <p:spPr>
           <a:xfrm>
-            <a:off x="3794760" y="1463040"/>
-            <a:ext cx="0" cy="4023360"/>
+            <a:off x="4503420" y="1463040"/>
+            <a:ext cx="0" cy="3337560"/>
           </a:xfrm>
           <a:prstGeom prst="line">
             <a:avLst/>
@@ -41143,8 +41143,8 @@
         </p:nvSpPr>
         <p:spPr>
           <a:xfrm>
-            <a:off x="685800" y="3474720"/>
-            <a:ext cx="6217920" cy="0"/>
+            <a:off x="2103120" y="3131820"/>
+            <a:ext cx="4800600" cy="0"/>
           </a:xfrm>
           <a:prstGeom prst="line">
             <a:avLst/>
@@ -41160,14 +41160,38 @@
       </p:sp>
       <p:sp>
         <p:nvSpPr>
-          <p:cNvPr id="11" name="Text 8"/>
+          <p:cNvPr id="11" name="Achse Nutzen"/>
+          <p:cNvSpPr/>
+          <p:nvPr/>
+        </p:nvSpPr>
+        <p:spPr>
+          <a:xfrm flipV="1">
+            <a:off x="1856232" y="1325880"/>
+            <a:ext cx="0" cy="3611880"/>
+          </a:xfrm>
+          <a:prstGeom prst="line">
+            <a:avLst/>
+          </a:prstGeom>
+          <a:noFill/>
+          <a:ln w="25400">
+            <a:solidFill>
+              <a:srgbClr val="12343B"/>
+            </a:solidFill>
+            <a:prstDash val="solid"/>
+            <a:tailEnd type="triangle"/>
+          </a:ln>
+        </p:spPr>
+      </p:sp>
+      <p:sp>
+        <p:nvSpPr>
+          <p:cNvPr id="12" name="Text 9"/>
           <p:cNvSpPr txBox="1"/>
           <p:nvPr/>
         </p:nvSpPr>
         <p:spPr>
           <a:xfrm>
-            <a:off x="685800" y="1417320"/>
-            <a:ext cx="2377440" cy="274320"/>
+            <a:off x="548640" y="1325880"/>
+            <a:ext cx="1234440" cy="274320"/>
           </a:xfrm>
           <a:prstGeom prst="rect">
             <a:avLst/>
@@ -41179,16 +41203,127 @@
           <a:bodyPr wrap="square" lIns="0" tIns="0" rIns="0" bIns="0" rtlCol="0" anchor="t"/>
           <a:lstStyle/>
           <a:p>
-            <a:pPr indent="0" marL="0">
+            <a:pPr algn="r" indent="0" marL="0">
+              <a:buNone/>
+            </a:pPr>
+            <a:r>
+              <a:rPr lang="en-US" sz="1200" b="1" dirty="0">
+                <a:solidFill>
+                  <a:schemeClr val="accent5"/>
+                </a:solidFill>
+              </a:rPr>
+              <a:t>hoch</a:t>
+            </a:r>
+            <a:endParaRPr lang="en-US" sz="1200" dirty="0"/>
+          </a:p>
+        </p:txBody>
+      </p:sp>
+      <p:sp>
+        <p:nvSpPr>
+          <p:cNvPr id="13" name="Text 10"/>
+          <p:cNvSpPr txBox="1"/>
+          <p:nvPr/>
+        </p:nvSpPr>
+        <p:spPr>
+          <a:xfrm>
+            <a:off x="548640" y="2240280"/>
+            <a:ext cx="1234440" cy="365760"/>
+          </a:xfrm>
+          <a:prstGeom prst="rect">
+            <a:avLst/>
+          </a:prstGeom>
+          <a:noFill/>
+          <a:ln/>
+        </p:spPr>
+        <p:txBody>
+          <a:bodyPr wrap="square" lIns="0" tIns="0" rIns="0" bIns="0" rtlCol="0" anchor="t"/>
+          <a:lstStyle/>
+          <a:p>
+            <a:pPr algn="r" indent="0" marL="0">
+              <a:buNone/>
+            </a:pPr>
+            <a:r>
+              <a:rPr lang="en-US" sz="1800" b="1" dirty="0">
+                <a:solidFill>
+                  <a:schemeClr val="tx2"/>
+                </a:solidFill>
+                <a:latin typeface="Cambria" pitchFamily="34" charset="0"/>
+                <a:ea typeface="Cambria" pitchFamily="34" charset="-122"/>
+                <a:cs typeface="Cambria" pitchFamily="34" charset="-120"/>
+              </a:rPr>
+              <a:t>Nutzen</a:t>
+            </a:r>
+            <a:endParaRPr lang="en-US" sz="1800" dirty="0"/>
+          </a:p>
+        </p:txBody>
+      </p:sp>
+      <p:sp>
+        <p:nvSpPr>
+          <p:cNvPr id="14" name="Text 11"/>
+          <p:cNvSpPr txBox="1"/>
+          <p:nvPr/>
+        </p:nvSpPr>
+        <p:spPr>
+          <a:xfrm>
+            <a:off x="548640" y="2624328"/>
+            <a:ext cx="1234440" cy="1188720"/>
+          </a:xfrm>
+          <a:prstGeom prst="rect">
+            <a:avLst/>
+          </a:prstGeom>
+          <a:noFill/>
+          <a:ln/>
+        </p:spPr>
+        <p:txBody>
+          <a:bodyPr wrap="square" lIns="0" tIns="0" rIns="0" bIns="0" rtlCol="0" anchor="t"/>
+          <a:lstStyle/>
+          <a:p>
+            <a:pPr algn="r" indent="0" marL="0">
               <a:buNone/>
             </a:pPr>
             <a:r>
               <a:rPr lang="en-US" sz="1200" dirty="0">
                 <a:solidFill>
+                  <a:schemeClr val="tx1"/>
+                </a:solidFill>
+              </a:rPr>
+              <a:t>Zeit gespart, Fehler vermieden, Rezeption entlastet</a:t>
+            </a:r>
+            <a:endParaRPr lang="en-US" sz="1200" dirty="0"/>
+          </a:p>
+        </p:txBody>
+      </p:sp>
+      <p:sp>
+        <p:nvSpPr>
+          <p:cNvPr id="15" name="Text 12"/>
+          <p:cNvSpPr txBox="1"/>
+          <p:nvPr/>
+        </p:nvSpPr>
+        <p:spPr>
+          <a:xfrm>
+            <a:off x="548640" y="4663440"/>
+            <a:ext cx="1234440" cy="274320"/>
+          </a:xfrm>
+          <a:prstGeom prst="rect">
+            <a:avLst/>
+          </a:prstGeom>
+          <a:noFill/>
+          <a:ln/>
+        </p:spPr>
+        <p:txBody>
+          <a:bodyPr wrap="square" lIns="0" tIns="0" rIns="0" bIns="0" rtlCol="0" anchor="t"/>
+          <a:lstStyle/>
+          <a:p>
+            <a:pPr algn="r" indent="0" marL="0">
+              <a:buNone/>
+            </a:pPr>
+            <a:r>
+              <a:rPr lang="en-US" sz="1200" b="1" dirty="0">
+                <a:solidFill>
                   <a:schemeClr val="accent5"/>
                 </a:solidFill>
               </a:rPr>
-              <a:t>↑ Nutzen für die Praxis</a:t>
+              <a:t>gering</a:t>
             </a:r>
             <a:endParaRPr lang="en-US" sz="1200" dirty="0"/>
           </a:p>
@@ -41196,14 +41331,149 @@
       </p:sp>
       <p:sp>
         <p:nvSpPr>
-          <p:cNvPr id="12" name="Text 9"/>
+          <p:cNvPr id="16" name="Achse Machbarkeit"/>
+          <p:cNvSpPr/>
+          <p:nvPr/>
+        </p:nvSpPr>
+        <p:spPr>
+          <a:xfrm>
+            <a:off x="1965960" y="5047488"/>
+            <a:ext cx="5074920" cy="0"/>
+          </a:xfrm>
+          <a:prstGeom prst="line">
+            <a:avLst/>
+          </a:prstGeom>
+          <a:noFill/>
+          <a:ln w="25400">
+            <a:solidFill>
+              <a:srgbClr val="12343B"/>
+            </a:solidFill>
+            <a:prstDash val="solid"/>
+            <a:tailEnd type="triangle"/>
+          </a:ln>
+        </p:spPr>
+      </p:sp>
+      <p:sp>
+        <p:nvSpPr>
+          <p:cNvPr id="17" name="Text 14"/>
           <p:cNvSpPr txBox="1"/>
           <p:nvPr/>
         </p:nvSpPr>
         <p:spPr>
           <a:xfrm>
-            <a:off x="548640" y="5696712"/>
-            <a:ext cx="6492240" cy="274320"/>
+            <a:off x="1965960" y="5120640"/>
+            <a:ext cx="914400" cy="274320"/>
+          </a:xfrm>
+          <a:prstGeom prst="rect">
+            <a:avLst/>
+          </a:prstGeom>
+          <a:noFill/>
+          <a:ln/>
+        </p:spPr>
+        <p:txBody>
+          <a:bodyPr wrap="square" lIns="0" tIns="0" rIns="0" bIns="0" rtlCol="0" anchor="t"/>
+          <a:lstStyle/>
+          <a:p>
+            <a:pPr indent="0" marL="0">
+              <a:buNone/>
+            </a:pPr>
+            <a:r>
+              <a:rPr lang="en-US" sz="1200" b="1" dirty="0">
+                <a:solidFill>
+                  <a:schemeClr val="accent5"/>
+                </a:solidFill>
+              </a:rPr>
+              <a:t>gering</a:t>
+            </a:r>
+            <a:endParaRPr lang="en-US" sz="1200" dirty="0"/>
+          </a:p>
+        </p:txBody>
+      </p:sp>
+      <p:sp>
+        <p:nvSpPr>
+          <p:cNvPr id="18" name="Text 15"/>
+          <p:cNvSpPr txBox="1"/>
+          <p:nvPr/>
+        </p:nvSpPr>
+        <p:spPr>
+          <a:xfrm>
+            <a:off x="6126480" y="5120640"/>
+            <a:ext cx="914400" cy="274320"/>
+          </a:xfrm>
+          <a:prstGeom prst="rect">
+            <a:avLst/>
+          </a:prstGeom>
+          <a:noFill/>
+          <a:ln/>
+        </p:spPr>
+        <p:txBody>
+          <a:bodyPr wrap="square" lIns="0" tIns="0" rIns="0" bIns="0" rtlCol="0" anchor="t"/>
+          <a:lstStyle/>
+          <a:p>
+            <a:pPr algn="r" indent="0" marL="0">
+              <a:buNone/>
+            </a:pPr>
+            <a:r>
+              <a:rPr lang="en-US" sz="1200" b="1" dirty="0">
+                <a:solidFill>
+                  <a:schemeClr val="accent5"/>
+                </a:solidFill>
+              </a:rPr>
+              <a:t>hoch</a:t>
+            </a:r>
+            <a:endParaRPr lang="en-US" sz="1200" dirty="0"/>
+          </a:p>
+        </p:txBody>
+      </p:sp>
+      <p:sp>
+        <p:nvSpPr>
+          <p:cNvPr id="19" name="Text 16"/>
+          <p:cNvSpPr txBox="1"/>
+          <p:nvPr/>
+        </p:nvSpPr>
+        <p:spPr>
+          <a:xfrm>
+            <a:off x="2880360" y="5120640"/>
+            <a:ext cx="3246120" cy="365760"/>
+          </a:xfrm>
+          <a:prstGeom prst="rect">
+            <a:avLst/>
+          </a:prstGeom>
+          <a:noFill/>
+          <a:ln/>
+        </p:spPr>
+        <p:txBody>
+          <a:bodyPr wrap="square" lIns="0" tIns="0" rIns="0" bIns="0" rtlCol="0" anchor="t"/>
+          <a:lstStyle/>
+          <a:p>
+            <a:pPr algn="ctr" indent="0" marL="0">
+              <a:buNone/>
+            </a:pPr>
+            <a:r>
+              <a:rPr lang="en-US" sz="1800" b="1" dirty="0">
+                <a:solidFill>
+                  <a:schemeClr val="tx2"/>
+                </a:solidFill>
+                <a:latin typeface="Cambria" pitchFamily="34" charset="0"/>
+                <a:ea typeface="Cambria" pitchFamily="34" charset="-122"/>
+                <a:cs typeface="Cambria" pitchFamily="34" charset="-120"/>
+              </a:rPr>
+              <a:t>Machbarkeit</a:t>
+            </a:r>
+            <a:endParaRPr lang="en-US" sz="1800" dirty="0"/>
+          </a:p>
+        </p:txBody>
+      </p:sp>
+      <p:sp>
+        <p:nvSpPr>
+          <p:cNvPr id="20" name="Text 17"/>
+          <p:cNvSpPr txBox="1"/>
+          <p:nvPr/>
+        </p:nvSpPr>
+        <p:spPr>
+          <a:xfrm>
+            <a:off x="1691640" y="5504688"/>
+            <a:ext cx="5623560" cy="457200"/>
           </a:xfrm>
           <a:prstGeom prst="rect">
             <a:avLst/>
@@ -41221,10 +41491,10 @@
             <a:r>
               <a:rPr lang="en-US" sz="1200" dirty="0">
                 <a:solidFill>
-                  <a:schemeClr val="accent5"/>
+                  <a:schemeClr val="tx1"/>
                 </a:solidFill>
               </a:rPr>
-              <a:t>Machbarkeit (Daten, Schnittstellen, Risiko) →</a:t>
+              <a:t>Daten vorhanden, ohne Schnittstelle zur Praxissoftware umsetzbar, geringes Risiko (Datenschutz, Fehlentscheidung)</a:t>
             </a:r>
             <a:endParaRPr lang="en-US" sz="1200" dirty="0"/>
           </a:p>
@@ -41232,7 +41502,7 @@
       </p:sp>
       <p:sp>
         <p:nvSpPr>
-          <p:cNvPr id="13" name="Einsatzfeld Verordnungs-Check"/>
+          <p:cNvPr id="21" name="Einsatzfeld Verordnungs-Check"/>
           <p:cNvSpPr/>
           <p:nvPr/>
         </p:nvSpPr>
@@ -41252,7 +41522,7 @@
       </p:sp>
       <p:sp>
         <p:nvSpPr>
-          <p:cNvPr id="14" name="Text 11"/>
+          <p:cNvPr id="22" name="Text 19"/>
           <p:cNvSpPr txBox="1"/>
           <p:nvPr/>
         </p:nvSpPr>
@@ -41288,13 +41558,13 @@
       </p:sp>
       <p:sp>
         <p:nvSpPr>
-          <p:cNvPr id="15" name="Einsatzfeld Terminvergabe &amp; Telefon"/>
+          <p:cNvPr id="23" name="Einsatzfeld Terminvergabe &amp; Telefon"/>
           <p:cNvSpPr/>
           <p:nvPr/>
         </p:nvSpPr>
         <p:spPr>
           <a:xfrm>
-            <a:off x="3666744" y="1563624"/>
+            <a:off x="4375404" y="1563624"/>
             <a:ext cx="256032" cy="256032"/>
           </a:xfrm>
           <a:prstGeom prst="ellipse">
@@ -41308,13 +41578,13 @@
       </p:sp>
       <p:sp>
         <p:nvSpPr>
-          <p:cNvPr id="16" name="Text 13"/>
+          <p:cNvPr id="24" name="Text 21"/>
           <p:cNvSpPr txBox="1"/>
           <p:nvPr/>
         </p:nvSpPr>
         <p:spPr>
           <a:xfrm>
-            <a:off x="1289304" y="1527048"/>
+            <a:off x="1997964" y="1527048"/>
             <a:ext cx="2286000" cy="329184"/>
           </a:xfrm>
           <a:prstGeom prst="rect">
@@ -41344,13 +41614,13 @@
       </p:sp>
       <p:sp>
         <p:nvSpPr>
-          <p:cNvPr id="17" name="Einsatzfeld Erinnerungen an Patienten"/>
+          <p:cNvPr id="25" name="Einsatzfeld Erinnerungen an Patienten"/>
           <p:cNvSpPr/>
           <p:nvPr/>
         </p:nvSpPr>
         <p:spPr>
           <a:xfrm>
-            <a:off x="6547104" y="3346704"/>
+            <a:off x="6547104" y="3003804"/>
             <a:ext cx="256032" cy="256032"/>
           </a:xfrm>
           <a:prstGeom prst="ellipse">
@@ -41364,13 +41634,13 @@
       </p:sp>
       <p:sp>
         <p:nvSpPr>
-          <p:cNvPr id="18" name="Text 15"/>
+          <p:cNvPr id="26" name="Text 23"/>
           <p:cNvSpPr txBox="1"/>
           <p:nvPr/>
         </p:nvSpPr>
         <p:spPr>
           <a:xfrm>
-            <a:off x="4169664" y="3310128"/>
+            <a:off x="4169664" y="2967228"/>
             <a:ext cx="2286000" cy="329184"/>
           </a:xfrm>
           <a:prstGeom prst="rect">
@@ -41400,13 +41670,13 @@
       </p:sp>
       <p:sp>
         <p:nvSpPr>
-          <p:cNvPr id="19" name="Einsatzfeld Abrechnungs-Vorbereitung"/>
+          <p:cNvPr id="27" name="Einsatzfeld Abrechnungs-Vorbereitung"/>
           <p:cNvSpPr/>
           <p:nvPr/>
         </p:nvSpPr>
         <p:spPr>
           <a:xfrm>
-            <a:off x="786384" y="3346704"/>
+            <a:off x="2203704" y="3003804"/>
             <a:ext cx="256032" cy="256032"/>
           </a:xfrm>
           <a:prstGeom prst="ellipse">
@@ -41420,13 +41690,13 @@
       </p:sp>
       <p:sp>
         <p:nvSpPr>
-          <p:cNvPr id="20" name="Text 17"/>
+          <p:cNvPr id="28" name="Text 25"/>
           <p:cNvSpPr txBox="1"/>
           <p:nvPr/>
         </p:nvSpPr>
         <p:spPr>
           <a:xfrm>
-            <a:off x="1115568" y="3310128"/>
+            <a:off x="2532888" y="2967228"/>
             <a:ext cx="2286000" cy="329184"/>
           </a:xfrm>
           <a:prstGeom prst="rect">
@@ -41456,13 +41726,13 @@
       </p:sp>
       <p:sp>
         <p:nvSpPr>
-          <p:cNvPr id="21" name="Einsatzfeld Therapieberichte an Ärzte"/>
+          <p:cNvPr id="29" name="Einsatzfeld Therapieberichte an Ärzte"/>
           <p:cNvSpPr/>
           <p:nvPr/>
         </p:nvSpPr>
         <p:spPr>
           <a:xfrm>
-            <a:off x="3666744" y="4238244"/>
+            <a:off x="4375404" y="3723894"/>
             <a:ext cx="256032" cy="256032"/>
           </a:xfrm>
           <a:prstGeom prst="ellipse">
@@ -41476,13 +41746,13 @@
       </p:sp>
       <p:sp>
         <p:nvSpPr>
-          <p:cNvPr id="22" name="Text 19"/>
+          <p:cNvPr id="30" name="Text 27"/>
           <p:cNvSpPr txBox="1"/>
           <p:nvPr/>
         </p:nvSpPr>
         <p:spPr>
           <a:xfrm>
-            <a:off x="3995928" y="4201668"/>
+            <a:off x="4704588" y="3687318"/>
             <a:ext cx="2286000" cy="329184"/>
           </a:xfrm>
           <a:prstGeom prst="rect">
@@ -41512,13 +41782,13 @@
       </p:sp>
       <p:sp>
         <p:nvSpPr>
-          <p:cNvPr id="23" name="Einsatzfeld Dienst- &amp; Raumplanung"/>
+          <p:cNvPr id="31" name="Einsatzfeld Dienst- &amp; Raumplanung"/>
           <p:cNvSpPr/>
           <p:nvPr/>
         </p:nvSpPr>
         <p:spPr>
           <a:xfrm>
-            <a:off x="3666744" y="5129784"/>
+            <a:off x="4375404" y="4443984"/>
             <a:ext cx="256032" cy="256032"/>
           </a:xfrm>
           <a:prstGeom prst="ellipse">
@@ -41532,13 +41802,13 @@
       </p:sp>
       <p:sp>
         <p:nvSpPr>
-          <p:cNvPr id="24" name="Text 21"/>
+          <p:cNvPr id="32" name="Text 29"/>
           <p:cNvSpPr txBox="1"/>
           <p:nvPr/>
         </p:nvSpPr>
         <p:spPr>
           <a:xfrm>
-            <a:off x="3995928" y="5093208"/>
+            <a:off x="4704588" y="4407408"/>
             <a:ext cx="2286000" cy="329184"/>
           </a:xfrm>
           <a:prstGeom prst="rect">
@@ -41568,7 +41838,7 @@
       </p:sp>
       <p:sp>
         <p:nvSpPr>
-          <p:cNvPr id="25" name="Begründung Pilot"/>
+          <p:cNvPr id="33" name="Begründung Pilot"/>
           <p:cNvSpPr/>
           <p:nvPr/>
         </p:nvSpPr>
@@ -41590,7 +41860,7 @@
       </p:sp>
       <p:sp>
         <p:nvSpPr>
-          <p:cNvPr id="26" name="Symbolkreis"/>
+          <p:cNvPr id="34" name="Symbolkreis"/>
           <p:cNvSpPr/>
           <p:nvPr/>
         </p:nvSpPr>
@@ -41610,7 +41880,7 @@
       </p:sp>
       <p:pic>
         <p:nvPicPr>
-          <p:cNvPr id="27" name="Symbol" descr="preencoded.png">    </p:cNvPr>
+          <p:cNvPr id="35" name="Symbol" descr="preencoded.png">    </p:cNvPr>
           <p:cNvPicPr>
             <a:picLocks noChangeAspect="1"/>
           </p:cNvPicPr>
@@ -41634,7 +41904,7 @@
       </p:pic>
       <p:sp>
         <p:nvSpPr>
-          <p:cNvPr id="28" name="Text 24"/>
+          <p:cNvPr id="36" name="Text 32"/>
           <p:cNvSpPr txBox="1"/>
           <p:nvPr/>
         </p:nvSpPr>
@@ -41673,7 +41943,7 @@
       </p:sp>
       <p:sp>
         <p:nvSpPr>
-          <p:cNvPr id="29" name="Text 25"/>
+          <p:cNvPr id="37" name="Text 33"/>
           <p:cNvSpPr txBox="1"/>
           <p:nvPr/>
         </p:nvSpPr>
@@ -41785,7 +42055,7 @@
       </p:sp>
       <p:sp>
         <p:nvSpPr>
-          <p:cNvPr id="30" name="Text 26"/>
+          <p:cNvPr id="38" name="Text 34"/>
           <p:cNvSpPr txBox="1"/>
           <p:nvPr/>
         </p:nvSpPr>

</xml_diff>